<commit_message>
Add backward-compatible template versioning for PPTX exporter
- Add Question/Answer/Plug slide layouts to template.pptx at indices 1-3,
  with Blank duplicated at index 6 for backward compatibility
- Gate specialized layouts behind template_version config key (default 1
  uses BLANK_SLIDE for all, version 2 uses distinct layouts)
- Allow overriding slide layout indices via config (question_slide_index, etc.)
- Add heading font helpers (_get_heading_font_name, _apply_font_to_text_frame)
  for configurable heading fonts on title/section slides
- Set template_version = 2 in default pptx_config.toml

Co-Authored-By: Anton Berezanskiy <a.berez2001@gmail.com>
Co-Authored-By: Claude Opus 4.6 <noreply@anthropic.com>
</commit_message>
<xml_diff>
--- a/chgksuite/chgksuite/resources/template.pptx
+++ b/chgksuite/chgksuite/resources/template.pptx
@@ -654,6 +654,576 @@
 </p:sldLayout>
 </file>
 
+<file path=ppt/slideLayouts/slideLayout12.xml><?xml version="1.0" encoding="utf-8"?>
+<p:sldLayout xmlns:a="http://schemas.openxmlformats.org/drawingml/2006/main" xmlns:r="http://schemas.openxmlformats.org/officeDocument/2006/relationships" xmlns:p="http://schemas.openxmlformats.org/presentationml/2006/main" type="blank" preserve="1">
+  <p:cSld name="QUESTION_SLIDE">
+    <p:spTree>
+      <p:nvGrpSpPr>
+        <p:cNvPr id="1" name=""/>
+        <p:cNvGrpSpPr/>
+        <p:nvPr/>
+      </p:nvGrpSpPr>
+      <p:grpSpPr>
+        <a:xfrm>
+          <a:off x="0" y="0"/>
+          <a:ext cx="0" cy="0"/>
+          <a:chOff x="0" y="0"/>
+          <a:chExt cx="0" cy="0"/>
+        </a:xfrm>
+      </p:grpSpPr>
+      <p:sp>
+        <p:nvSpPr>
+          <p:cNvPr id="2" name="Date Placeholder 1"/>
+          <p:cNvSpPr>
+            <a:spLocks noGrp="1"/>
+          </p:cNvSpPr>
+          <p:nvPr>
+            <p:ph type="dt" sz="half" idx="10"/>
+          </p:nvPr>
+        </p:nvSpPr>
+        <p:spPr/>
+        <p:txBody>
+          <a:bodyPr/>
+          <a:lstStyle/>
+          <a:p>
+            <a:fld id="{85B019E5-EBD6-D94B-AB4E-89C76F7E930C}" type="datetimeFigureOut">
+              <a:rPr lang="en-RU"/>
+              <a:t>15.11.2020</a:t>
+            </a:fld>
+            <a:endParaRPr lang="en-RU"/>
+          </a:p>
+        </p:txBody>
+      </p:sp>
+      <p:sp>
+        <p:nvSpPr>
+          <p:cNvPr id="3" name="Footer Placeholder 2"/>
+          <p:cNvSpPr>
+            <a:spLocks noGrp="1"/>
+          </p:cNvSpPr>
+          <p:nvPr>
+            <p:ph type="ftr" sz="quarter" idx="11"/>
+          </p:nvPr>
+        </p:nvSpPr>
+        <p:spPr/>
+        <p:txBody>
+          <a:bodyPr/>
+          <a:lstStyle/>
+          <a:p>
+            <a:endParaRPr lang="en-RU"/>
+          </a:p>
+        </p:txBody>
+      </p:sp>
+      <p:sp>
+        <p:nvSpPr>
+          <p:cNvPr id="4" name="Slide Number Placeholder 3"/>
+          <p:cNvSpPr>
+            <a:spLocks noGrp="1"/>
+          </p:cNvSpPr>
+          <p:nvPr>
+            <p:ph type="sldNum" sz="quarter" idx="12"/>
+          </p:nvPr>
+        </p:nvSpPr>
+        <p:spPr/>
+        <p:txBody>
+          <a:bodyPr/>
+          <a:lstStyle/>
+          <a:p>
+            <a:fld id="{58B0DF76-597F-6E4B-8359-0D2C6B0DD526}" type="slidenum">
+              <a:rPr lang="en-RU"/>
+              <a:t>‹#›</a:t>
+            </a:fld>
+            <a:endParaRPr lang="en-RU"/>
+          </a:p>
+        </p:txBody>
+      </p:sp>
+    </p:spTree>
+    <p:extLst>
+      <p:ext uri="{BB962C8B-B14F-4D97-AF65-F5344CB8AC3E}">
+        <p14:creationId xmlns:p14="http://schemas.microsoft.com/office/powerpoint/2010/main" val="217403303"/>
+      </p:ext>
+    </p:extLst>
+  </p:cSld>
+  <p:clrMapOvr>
+    <a:masterClrMapping/>
+  </p:clrMapOvr>
+</p:sldLayout>
+</file>
+
+<file path=ppt/slideLayouts/slideLayout13.xml><?xml version="1.0" encoding="utf-8"?>
+<p:sldLayout xmlns:a="http://schemas.openxmlformats.org/drawingml/2006/main" xmlns:r="http://schemas.openxmlformats.org/officeDocument/2006/relationships" xmlns:p="http://schemas.openxmlformats.org/presentationml/2006/main" type="blank" preserve="1">
+  <p:cSld name="ANSWER_SLIDE">
+    <p:spTree>
+      <p:nvGrpSpPr>
+        <p:cNvPr id="1" name=""/>
+        <p:cNvGrpSpPr/>
+        <p:nvPr/>
+      </p:nvGrpSpPr>
+      <p:grpSpPr>
+        <a:xfrm>
+          <a:off x="0" y="0"/>
+          <a:ext cx="0" cy="0"/>
+          <a:chOff x="0" y="0"/>
+          <a:chExt cx="0" cy="0"/>
+        </a:xfrm>
+      </p:grpSpPr>
+      <p:sp>
+        <p:nvSpPr>
+          <p:cNvPr id="2" name="Date Placeholder 1"/>
+          <p:cNvSpPr>
+            <a:spLocks noGrp="1"/>
+          </p:cNvSpPr>
+          <p:nvPr>
+            <p:ph type="dt" sz="half" idx="10"/>
+          </p:nvPr>
+        </p:nvSpPr>
+        <p:spPr/>
+        <p:txBody>
+          <a:bodyPr/>
+          <a:lstStyle/>
+          <a:p>
+            <a:fld id="{85B019E5-EBD6-D94B-AB4E-89C76F7E930C}" type="datetimeFigureOut">
+              <a:rPr lang="en-RU"/>
+              <a:t>15.11.2020</a:t>
+            </a:fld>
+            <a:endParaRPr lang="en-RU"/>
+          </a:p>
+        </p:txBody>
+      </p:sp>
+      <p:sp>
+        <p:nvSpPr>
+          <p:cNvPr id="3" name="Footer Placeholder 2"/>
+          <p:cNvSpPr>
+            <a:spLocks noGrp="1"/>
+          </p:cNvSpPr>
+          <p:nvPr>
+            <p:ph type="ftr" sz="quarter" idx="11"/>
+          </p:nvPr>
+        </p:nvSpPr>
+        <p:spPr/>
+        <p:txBody>
+          <a:bodyPr/>
+          <a:lstStyle/>
+          <a:p>
+            <a:endParaRPr lang="en-RU"/>
+          </a:p>
+        </p:txBody>
+      </p:sp>
+      <p:sp>
+        <p:nvSpPr>
+          <p:cNvPr id="4" name="Slide Number Placeholder 3"/>
+          <p:cNvSpPr>
+            <a:spLocks noGrp="1"/>
+          </p:cNvSpPr>
+          <p:nvPr>
+            <p:ph type="sldNum" sz="quarter" idx="12"/>
+          </p:nvPr>
+        </p:nvSpPr>
+        <p:spPr/>
+        <p:txBody>
+          <a:bodyPr/>
+          <a:lstStyle/>
+          <a:p>
+            <a:fld id="{58B0DF76-597F-6E4B-8359-0D2C6B0DD526}" type="slidenum">
+              <a:rPr lang="en-RU"/>
+              <a:t>‹#›</a:t>
+            </a:fld>
+            <a:endParaRPr lang="en-RU"/>
+          </a:p>
+        </p:txBody>
+      </p:sp>
+    </p:spTree>
+    <p:extLst>
+      <p:ext uri="{BB962C8B-B14F-4D97-AF65-F5344CB8AC3E}">
+        <p14:creationId xmlns:p14="http://schemas.microsoft.com/office/powerpoint/2010/main" val="291478801"/>
+      </p:ext>
+    </p:extLst>
+  </p:cSld>
+  <p:clrMapOvr>
+    <a:masterClrMapping/>
+  </p:clrMapOvr>
+</p:sldLayout>
+</file>
+
+<file path=ppt/slideLayouts/slideLayout14.xml><?xml version="1.0" encoding="utf-8"?>
+<p:sldLayout xmlns:a="http://schemas.openxmlformats.org/drawingml/2006/main" xmlns:r="http://schemas.openxmlformats.org/officeDocument/2006/relationships" xmlns:p="http://schemas.openxmlformats.org/presentationml/2006/main" type="blank" preserve="1">
+  <p:cSld name="PLUG_SLIDE">
+    <p:spTree>
+      <p:nvGrpSpPr>
+        <p:cNvPr id="1" name=""/>
+        <p:cNvGrpSpPr/>
+        <p:nvPr/>
+      </p:nvGrpSpPr>
+      <p:grpSpPr>
+        <a:xfrm>
+          <a:off x="0" y="0"/>
+          <a:ext cx="0" cy="0"/>
+          <a:chOff x="0" y="0"/>
+          <a:chExt cx="0" cy="0"/>
+        </a:xfrm>
+      </p:grpSpPr>
+      <p:sp>
+        <p:nvSpPr>
+          <p:cNvPr id="2" name="Date Placeholder 1"/>
+          <p:cNvSpPr>
+            <a:spLocks noGrp="1"/>
+          </p:cNvSpPr>
+          <p:nvPr>
+            <p:ph type="dt" sz="half" idx="10"/>
+          </p:nvPr>
+        </p:nvSpPr>
+        <p:spPr/>
+        <p:txBody>
+          <a:bodyPr/>
+          <a:lstStyle/>
+          <a:p>
+            <a:fld id="{85B019E5-EBD6-D94B-AB4E-89C76F7E930C}" type="datetimeFigureOut">
+              <a:rPr lang="en-RU"/>
+              <a:t>15.11.2020</a:t>
+            </a:fld>
+            <a:endParaRPr lang="en-RU"/>
+          </a:p>
+        </p:txBody>
+      </p:sp>
+      <p:sp>
+        <p:nvSpPr>
+          <p:cNvPr id="3" name="Footer Placeholder 2"/>
+          <p:cNvSpPr>
+            <a:spLocks noGrp="1"/>
+          </p:cNvSpPr>
+          <p:nvPr>
+            <p:ph type="ftr" sz="quarter" idx="11"/>
+          </p:nvPr>
+        </p:nvSpPr>
+        <p:spPr/>
+        <p:txBody>
+          <a:bodyPr/>
+          <a:lstStyle/>
+          <a:p>
+            <a:endParaRPr lang="en-RU"/>
+          </a:p>
+        </p:txBody>
+      </p:sp>
+      <p:sp>
+        <p:nvSpPr>
+          <p:cNvPr id="4" name="Slide Number Placeholder 3"/>
+          <p:cNvSpPr>
+            <a:spLocks noGrp="1"/>
+          </p:cNvSpPr>
+          <p:nvPr>
+            <p:ph type="sldNum" sz="quarter" idx="12"/>
+          </p:nvPr>
+        </p:nvSpPr>
+        <p:spPr/>
+        <p:txBody>
+          <a:bodyPr/>
+          <a:lstStyle/>
+          <a:p>
+            <a:fld id="{58B0DF76-597F-6E4B-8359-0D2C6B0DD526}" type="slidenum">
+              <a:rPr lang="en-RU"/>
+              <a:t>‹#›</a:t>
+            </a:fld>
+            <a:endParaRPr lang="en-RU"/>
+          </a:p>
+        </p:txBody>
+      </p:sp>
+    </p:spTree>
+    <p:extLst>
+      <p:ext uri="{BB962C8B-B14F-4D97-AF65-F5344CB8AC3E}">
+        <p14:creationId xmlns:p14="http://schemas.microsoft.com/office/powerpoint/2010/main" val="2052174700"/>
+      </p:ext>
+    </p:extLst>
+  </p:cSld>
+  <p:clrMapOvr>
+    <a:masterClrMapping/>
+  </p:clrMapOvr>
+</p:sldLayout>
+</file>
+
+<file path=ppt/slideLayouts/slideLayout15.xml><?xml version="1.0" encoding="utf-8"?>
+<p:sldLayout xmlns:a="http://schemas.openxmlformats.org/drawingml/2006/main" xmlns:r="http://schemas.openxmlformats.org/officeDocument/2006/relationships" xmlns:p="http://schemas.openxmlformats.org/presentationml/2006/main" type="blank" preserve="1">
+  <p:cSld name="BLANK_SLIDE">
+    <p:spTree>
+      <p:nvGrpSpPr>
+        <p:cNvPr id="1" name=""/>
+        <p:cNvGrpSpPr/>
+        <p:nvPr/>
+      </p:nvGrpSpPr>
+      <p:grpSpPr>
+        <a:xfrm>
+          <a:off x="0" y="0"/>
+          <a:ext cx="0" cy="0"/>
+          <a:chOff x="0" y="0"/>
+          <a:chExt cx="0" cy="0"/>
+        </a:xfrm>
+      </p:grpSpPr>
+      <p:sp>
+        <p:nvSpPr>
+          <p:cNvPr id="2" name="Date Placeholder 1"/>
+          <p:cNvSpPr>
+            <a:spLocks noGrp="1"/>
+          </p:cNvSpPr>
+          <p:nvPr>
+            <p:ph type="dt" sz="half" idx="10"/>
+          </p:nvPr>
+        </p:nvSpPr>
+        <p:spPr/>
+        <p:txBody>
+          <a:bodyPr/>
+          <a:lstStyle/>
+          <a:p>
+            <a:fld id="{85B019E5-EBD6-D94B-AB4E-89C76F7E930C}" type="datetimeFigureOut">
+              <a:rPr lang="en-RU"/>
+              <a:t>15.11.2020</a:t>
+            </a:fld>
+            <a:endParaRPr lang="en-RU"/>
+          </a:p>
+        </p:txBody>
+      </p:sp>
+      <p:sp>
+        <p:nvSpPr>
+          <p:cNvPr id="3" name="Footer Placeholder 2"/>
+          <p:cNvSpPr>
+            <a:spLocks noGrp="1"/>
+          </p:cNvSpPr>
+          <p:nvPr>
+            <p:ph type="ftr" sz="quarter" idx="11"/>
+          </p:nvPr>
+        </p:nvSpPr>
+        <p:spPr/>
+        <p:txBody>
+          <a:bodyPr/>
+          <a:lstStyle/>
+          <a:p>
+            <a:endParaRPr lang="en-RU"/>
+          </a:p>
+        </p:txBody>
+      </p:sp>
+      <p:sp>
+        <p:nvSpPr>
+          <p:cNvPr id="4" name="Slide Number Placeholder 3"/>
+          <p:cNvSpPr>
+            <a:spLocks noGrp="1"/>
+          </p:cNvSpPr>
+          <p:nvPr>
+            <p:ph type="sldNum" sz="quarter" idx="12"/>
+          </p:nvPr>
+        </p:nvSpPr>
+        <p:spPr/>
+        <p:txBody>
+          <a:bodyPr/>
+          <a:lstStyle/>
+          <a:p>
+            <a:fld id="{58B0DF76-597F-6E4B-8359-0D2C6B0DD526}" type="slidenum">
+              <a:rPr lang="en-RU"/>
+              <a:t>‹#›</a:t>
+            </a:fld>
+            <a:endParaRPr lang="en-RU"/>
+          </a:p>
+        </p:txBody>
+      </p:sp>
+    </p:spTree>
+    <p:extLst>
+      <p:ext uri="{BB962C8B-B14F-4D97-AF65-F5344CB8AC3E}">
+        <p14:creationId xmlns:p14="http://schemas.microsoft.com/office/powerpoint/2010/main" val="1922657811"/>
+      </p:ext>
+    </p:extLst>
+  </p:cSld>
+  <p:clrMapOvr>
+    <a:masterClrMapping/>
+  </p:clrMapOvr>
+</p:sldLayout>
+</file>
+
+<file path=ppt/slideLayouts/slideLayout16.xml><?xml version="1.0" encoding="utf-8"?>
+<p:sldLayout xmlns:a="http://schemas.openxmlformats.org/drawingml/2006/main" xmlns:r="http://schemas.openxmlformats.org/officeDocument/2006/relationships" xmlns:p="http://schemas.openxmlformats.org/presentationml/2006/main" type="blank" preserve="1">
+  <p:cSld name="BLANK_SLIDE_5">
+    <p:spTree>
+      <p:nvGrpSpPr>
+        <p:cNvPr id="1" name=""/>
+        <p:cNvGrpSpPr/>
+        <p:nvPr/>
+      </p:nvGrpSpPr>
+      <p:grpSpPr>
+        <a:xfrm>
+          <a:off x="0" y="0"/>
+          <a:ext cx="0" cy="0"/>
+          <a:chOff x="0" y="0"/>
+          <a:chExt cx="0" cy="0"/>
+        </a:xfrm>
+      </p:grpSpPr>
+      <p:sp>
+        <p:nvSpPr>
+          <p:cNvPr id="2" name="Date Placeholder 1"/>
+          <p:cNvSpPr>
+            <a:spLocks noGrp="1"/>
+          </p:cNvSpPr>
+          <p:nvPr>
+            <p:ph type="dt" sz="half" idx="10"/>
+          </p:nvPr>
+        </p:nvSpPr>
+        <p:spPr/>
+        <p:txBody>
+          <a:bodyPr/>
+          <a:lstStyle/>
+          <a:p>
+            <a:fld id="{85B019E5-EBD6-D94B-AB4E-89C76F7E930C}" type="datetimeFigureOut">
+              <a:rPr lang="en-RU"/>
+              <a:t>15.11.2020</a:t>
+            </a:fld>
+            <a:endParaRPr lang="en-RU"/>
+          </a:p>
+        </p:txBody>
+      </p:sp>
+      <p:sp>
+        <p:nvSpPr>
+          <p:cNvPr id="3" name="Footer Placeholder 2"/>
+          <p:cNvSpPr>
+            <a:spLocks noGrp="1"/>
+          </p:cNvSpPr>
+          <p:nvPr>
+            <p:ph type="ftr" sz="quarter" idx="11"/>
+          </p:nvPr>
+        </p:nvSpPr>
+        <p:spPr/>
+        <p:txBody>
+          <a:bodyPr/>
+          <a:lstStyle/>
+          <a:p>
+            <a:endParaRPr lang="en-RU"/>
+          </a:p>
+        </p:txBody>
+      </p:sp>
+      <p:sp>
+        <p:nvSpPr>
+          <p:cNvPr id="4" name="Slide Number Placeholder 3"/>
+          <p:cNvSpPr>
+            <a:spLocks noGrp="1"/>
+          </p:cNvSpPr>
+          <p:nvPr>
+            <p:ph type="sldNum" sz="quarter" idx="12"/>
+          </p:nvPr>
+        </p:nvSpPr>
+        <p:spPr/>
+        <p:txBody>
+          <a:bodyPr/>
+          <a:lstStyle/>
+          <a:p>
+            <a:fld id="{58B0DF76-597F-6E4B-8359-0D2C6B0DD526}" type="slidenum">
+              <a:rPr lang="en-RU"/>
+              <a:t>‹#›</a:t>
+            </a:fld>
+            <a:endParaRPr lang="en-RU"/>
+          </a:p>
+        </p:txBody>
+      </p:sp>
+    </p:spTree>
+    <p:extLst>
+      <p:ext uri="{BB962C8B-B14F-4D97-AF65-F5344CB8AC3E}">
+        <p14:creationId xmlns:p14="http://schemas.microsoft.com/office/powerpoint/2010/main" val="398848246"/>
+      </p:ext>
+    </p:extLst>
+  </p:cSld>
+  <p:clrMapOvr>
+    <a:masterClrMapping/>
+  </p:clrMapOvr>
+</p:sldLayout>
+</file>
+
+<file path=ppt/slideLayouts/slideLayout17.xml><?xml version="1.0" encoding="utf-8"?>
+<p:sldLayout xmlns:a="http://schemas.openxmlformats.org/drawingml/2006/main" xmlns:r="http://schemas.openxmlformats.org/officeDocument/2006/relationships" xmlns:p="http://schemas.openxmlformats.org/presentationml/2006/main" type="blank" preserve="1">
+  <p:cSld name="BLANK_SLIDE_6">
+    <p:spTree>
+      <p:nvGrpSpPr>
+        <p:cNvPr id="1" name=""/>
+        <p:cNvGrpSpPr/>
+        <p:nvPr/>
+      </p:nvGrpSpPr>
+      <p:grpSpPr>
+        <a:xfrm>
+          <a:off x="0" y="0"/>
+          <a:ext cx="0" cy="0"/>
+          <a:chOff x="0" y="0"/>
+          <a:chExt cx="0" cy="0"/>
+        </a:xfrm>
+      </p:grpSpPr>
+      <p:sp>
+        <p:nvSpPr>
+          <p:cNvPr id="2" name="Date Placeholder 1"/>
+          <p:cNvSpPr>
+            <a:spLocks noGrp="1"/>
+          </p:cNvSpPr>
+          <p:nvPr>
+            <p:ph type="dt" sz="half" idx="10"/>
+          </p:nvPr>
+        </p:nvSpPr>
+        <p:spPr/>
+        <p:txBody>
+          <a:bodyPr/>
+          <a:lstStyle/>
+          <a:p>
+            <a:fld id="{85B019E5-EBD6-D94B-AB4E-89C76F7E930C}" type="datetimeFigureOut">
+              <a:rPr lang="en-RU"/>
+              <a:t>15.11.2020</a:t>
+            </a:fld>
+            <a:endParaRPr lang="en-RU"/>
+          </a:p>
+        </p:txBody>
+      </p:sp>
+      <p:sp>
+        <p:nvSpPr>
+          <p:cNvPr id="3" name="Footer Placeholder 2"/>
+          <p:cNvSpPr>
+            <a:spLocks noGrp="1"/>
+          </p:cNvSpPr>
+          <p:nvPr>
+            <p:ph type="ftr" sz="quarter" idx="11"/>
+          </p:nvPr>
+        </p:nvSpPr>
+        <p:spPr/>
+        <p:txBody>
+          <a:bodyPr/>
+          <a:lstStyle/>
+          <a:p>
+            <a:endParaRPr lang="en-RU"/>
+          </a:p>
+        </p:txBody>
+      </p:sp>
+      <p:sp>
+        <p:nvSpPr>
+          <p:cNvPr id="4" name="Slide Number Placeholder 3"/>
+          <p:cNvSpPr>
+            <a:spLocks noGrp="1"/>
+          </p:cNvSpPr>
+          <p:nvPr>
+            <p:ph type="sldNum" sz="quarter" idx="12"/>
+          </p:nvPr>
+        </p:nvSpPr>
+        <p:spPr/>
+        <p:txBody>
+          <a:bodyPr/>
+          <a:lstStyle/>
+          <a:p>
+            <a:fld id="{58B0DF76-597F-6E4B-8359-0D2C6B0DD526}" type="slidenum">
+              <a:rPr lang="en-RU"/>
+              <a:t>‹#›</a:t>
+            </a:fld>
+            <a:endParaRPr lang="en-RU"/>
+          </a:p>
+        </p:txBody>
+      </p:sp>
+    </p:spTree>
+    <p:extLst>
+      <p:ext uri="{BB962C8B-B14F-4D97-AF65-F5344CB8AC3E}">
+        <p14:creationId xmlns:p14="http://schemas.microsoft.com/office/powerpoint/2010/main" val="884158397"/>
+      </p:ext>
+    </p:extLst>
+  </p:cSld>
+  <p:clrMapOvr>
+    <a:masterClrMapping/>
+  </p:clrMapOvr>
+</p:sldLayout>
+</file>
+
 <file path=ppt/slideLayouts/slideLayout2.xml><?xml version="1.0" encoding="utf-8"?>
 <p:sldLayout xmlns:a="http://schemas.openxmlformats.org/drawingml/2006/main" xmlns:r="http://schemas.openxmlformats.org/officeDocument/2006/relationships" xmlns:p="http://schemas.openxmlformats.org/presentationml/2006/main" type="obj" preserve="1">
   <p:cSld name="Title and Content">
@@ -2662,16 +3232,12 @@
   <p:clrMap bg1="lt1" tx1="dk1" bg2="lt2" tx2="dk2" accent1="accent1" accent2="accent2" accent3="accent3" accent4="accent4" accent5="accent5" accent6="accent6" hlink="hlink" folHlink="folHlink"/>
   <p:sldLayoutIdLst>
     <p:sldLayoutId id="2147483673" r:id="rId1"/>
-    <p:sldLayoutId id="2147483674" r:id="rId2"/>
-    <p:sldLayoutId id="2147483675" r:id="rId3"/>
-    <p:sldLayoutId id="2147483676" r:id="rId4"/>
-    <p:sldLayoutId id="2147483677" r:id="rId5"/>
-    <p:sldLayoutId id="2147483678" r:id="rId6"/>
-    <p:sldLayoutId id="2147483679" r:id="rId7"/>
-    <p:sldLayoutId id="2147483680" r:id="rId8"/>
-    <p:sldLayoutId id="2147483681" r:id="rId9"/>
-    <p:sldLayoutId id="2147483682" r:id="rId10"/>
-    <p:sldLayoutId id="2147483683" r:id="rId11"/>
+    <p:sldLayoutId id="2147483684" r:id="rId13"/>
+    <p:sldLayoutId id="2147483685" r:id="rId14"/>
+    <p:sldLayoutId id="2147483686" r:id="rId15"/>
+    <p:sldLayoutId id="2147483687" r:id="rId16"/>
+    <p:sldLayoutId id="2147483688" r:id="rId17"/>
+    <p:sldLayoutId id="2147483689" r:id="rId18"/>
   </p:sldLayoutIdLst>
   <p:txStyles>
     <p:titleStyle>

</xml_diff>